<commit_message>
3-rd model qwen_v1 test
</commit_message>
<xml_diff>
--- a/files/AI Alignemnt Emotions all slides.pptx
+++ b/files/AI Alignemnt Emotions all slides.pptx
@@ -8,6 +8,14 @@
     <p:notesMasterId r:id="rId7"/>
   </p:notesMasterIdLst>
   <p:sldIdLst>
+    <p:sldId id="341" r:id="rId93"/>
+    <p:sldId id="342" r:id="rId94"/>
+    <p:sldId id="343" r:id="rId95"/>
+    <p:sldId id="344" r:id="rId96"/>
+    <p:sldId id="345" r:id="rId97"/>
+    <p:sldId id="346" r:id="rId98"/>
+    <p:sldId id="347" r:id="rId99"/>
+    <p:sldId id="348" r:id="rId100"/>
     <p:sldId id="335" r:id="rId87"/>
     <p:sldId id="336" r:id="rId88"/>
     <p:sldId id="337" r:id="rId89"/>
@@ -37809,6 +37817,1067 @@
 </p:sld>
 </file>
 
+<file path=ppt/slides/slide86.xml><?xml version="1.0" encoding="utf-8"?>
+<p:sld xmlns:a="http://schemas.openxmlformats.org/drawingml/2006/main" xmlns:p="http://schemas.openxmlformats.org/presentationml/2006/main" xmlns:r="http://schemas.openxmlformats.org/officeDocument/2006/relationships">
+  <p:cSld>
+    <p:spTree>
+      <p:nvGrpSpPr>
+        <p:cNvPr id="1" name=""/>
+        <p:cNvGrpSpPr/>
+        <p:nvPr/>
+      </p:nvGrpSpPr>
+      <p:grpSpPr/>
+      <p:sp>
+        <p:nvSpPr>
+          <p:cNvPr id="2" name="Title 1"/>
+          <p:cNvSpPr>
+            <a:spLocks noGrp="1"/>
+          </p:cNvSpPr>
+          <p:nvPr>
+            <p:ph type="ctrTitle"/>
+          </p:nvPr>
+        </p:nvSpPr>
+        <p:spPr/>
+        <p:txBody>
+          <a:bodyPr/>
+          <a:lstStyle/>
+          <a:p>
+            <a:pPr/>
+            <a:r>
+              <a:rPr>
+                <a:solidFill>
+                  <a:schemeClr val="dk1"/>
+                </a:solidFill>
+              </a:rPr>
+              <a:t>Second model: InternVL2.5-8B</a:t>
+            </a:r>
+          </a:p>
+        </p:txBody>
+      </p:sp>
+      <p:sp>
+        <p:nvSpPr>
+          <p:cNvPr id="3" name="Subtitle 2"/>
+          <p:cNvSpPr>
+            <a:spLocks noGrp="1"/>
+          </p:cNvSpPr>
+          <p:nvPr>
+            <p:ph type="subTitle" idx="1"/>
+          </p:nvPr>
+        </p:nvSpPr>
+        <p:spPr/>
+        <p:txBody>
+          <a:bodyPr/>
+          <a:lstStyle/>
+          <a:p>
+            <a:pPr/>
+            <a:r>
+              <a:rPr>
+                <a:solidFill>
+                  <a:schemeClr val="dk1"/>
+                </a:solidFill>
+              </a:rPr>
+              <a:t>25.10.2026</a:t>
+            </a:r>
+          </a:p>
+        </p:txBody>
+      </p:sp>
+    </p:spTree>
+  </p:cSld>
+  <p:clrMapOvr>
+    <a:masterClrMapping/>
+  </p:clrMapOvr>
+</p:sld>
+</file>
+
+<file path=ppt/slides/slide87.xml><?xml version="1.0" encoding="utf-8"?>
+<p:sld xmlns:a="http://schemas.openxmlformats.org/drawingml/2006/main" xmlns:p="http://schemas.openxmlformats.org/presentationml/2006/main" xmlns:r="http://schemas.openxmlformats.org/officeDocument/2006/relationships">
+  <p:cSld>
+    <p:spTree>
+      <p:nvGrpSpPr>
+        <p:cNvPr id="1" name=""/>
+        <p:cNvGrpSpPr/>
+        <p:nvPr/>
+      </p:nvGrpSpPr>
+      <p:grpSpPr/>
+      <p:sp>
+        <p:nvSpPr>
+          <p:cNvPr id="2" name="Title 1"/>
+          <p:cNvSpPr>
+            <a:spLocks noGrp="1"/>
+          </p:cNvSpPr>
+          <p:nvPr>
+            <p:ph type="title"/>
+          </p:nvPr>
+        </p:nvSpPr>
+        <p:spPr/>
+        <p:txBody>
+          <a:bodyPr/>
+          <a:lstStyle/>
+          <a:p>
+            <a:pPr/>
+            <a:r>
+              <a:rPr>
+                <a:solidFill>
+                  <a:schemeClr val="dk1"/>
+                </a:solidFill>
+              </a:rPr>
+              <a:t>Second model: InternVL2.5-8B</a:t>
+            </a:r>
+          </a:p>
+        </p:txBody>
+      </p:sp>
+      <p:sp>
+        <p:nvSpPr>
+          <p:cNvPr id="3" name="Text Placeholder 2"/>
+          <p:cNvSpPr>
+            <a:spLocks noGrp="1"/>
+          </p:cNvSpPr>
+          <p:nvPr>
+            <p:ph type="body" idx="1"/>
+          </p:nvPr>
+        </p:nvSpPr>
+        <p:spPr/>
+        <p:txBody>
+          <a:bodyPr/>
+          <a:lstStyle/>
+          <a:p>
+            <a:pPr/>
+            <a:r>
+              <a:rPr>
+                <a:solidFill>
+                  <a:schemeClr val="dk1"/>
+                </a:solidFill>
+              </a:rPr>
+              <a:t>The only non-Qwen open model evaluated in the MoMentS paper (InternLM2.5 language model, InternViT vision).</a:t>
+            </a:r>
+          </a:p>
+          <a:p>
+            <a:pPr lvl="1"/>
+            <a:r>
+              <a:rPr>
+                <a:solidFill>
+                  <a:schemeClr val="dk1"/>
+                </a:solidFill>
+              </a:rPr>
+              <a:t>Release used: OpenGVLab/InternVL2_5-8B-MPO-hf (runs natively in transformers).</a:t>
+            </a:r>
+          </a:p>
+          <a:p>
+            <a:pPr/>
+            <a:r>
+              <a:rPr>
+                <a:solidFill>
+                  <a:schemeClr val="dk1"/>
+                </a:solidFill>
+              </a:rPr>
+              <a:t>Same as Qwen: 598 questions, six conditions, prompts, option orders, 64 frames, both follow-up questions.</a:t>
+            </a:r>
+          </a:p>
+          <a:p>
+            <a:pPr lvl="1"/>
+            <a:r>
+              <a:rPr>
+                <a:solidFill>
+                  <a:schemeClr val="dk1"/>
+                </a:solidFill>
+              </a:rPr>
+              <a:t>Each frame is one 448x448 image; letter probabilities sum to 1.0 in every condition.</a:t>
+            </a:r>
+          </a:p>
+          <a:p>
+            <a:pPr/>
+            <a:r>
+              <a:rPr>
+                <a:solidFill>
+                  <a:schemeClr val="dk1"/>
+                </a:solidFill>
+              </a:rPr>
+              <a:t>Explanations coded by the same two judges, same prompt (notebook 09).</a:t>
+            </a:r>
+          </a:p>
+          <a:p>
+            <a:pPr lvl="1"/>
+            <a:r>
+              <a:rPr>
+                <a:solidFill>
+                  <a:schemeClr val="dk1"/>
+                </a:solidFill>
+              </a:rPr>
+              <a:t>Agreement: kappa 0.87 dialogue, 0.85 visual, 0.99 insufficient, 0.73 missing visual.</a:t>
+            </a:r>
+          </a:p>
+          <a:p>
+            <a:pPr/>
+            <a:r>
+              <a:rPr>
+                <a:solidFill>
+                  <a:schemeClr val="dk1"/>
+                </a:solidFill>
+              </a:rPr>
+              <a:t>Comparison in notebook 10.</a:t>
+            </a:r>
+          </a:p>
+        </p:txBody>
+      </p:sp>
+    </p:spTree>
+  </p:cSld>
+  <p:clrMapOvr>
+    <a:masterClrMapping/>
+  </p:clrMapOvr>
+</p:sld>
+</file>
+
+<file path=ppt/slides/slide88.xml><?xml version="1.0" encoding="utf-8"?>
+<p:sld xmlns:a="http://schemas.openxmlformats.org/drawingml/2006/main" xmlns:p="http://schemas.openxmlformats.org/presentationml/2006/main" xmlns:r="http://schemas.openxmlformats.org/officeDocument/2006/relationships">
+  <p:cSld>
+    <p:spTree>
+      <p:nvGrpSpPr>
+        <p:cNvPr id="1" name=""/>
+        <p:cNvGrpSpPr/>
+        <p:nvPr/>
+      </p:nvGrpSpPr>
+      <p:grpSpPr/>
+      <p:sp>
+        <p:nvSpPr>
+          <p:cNvPr id="2" name="Title 1"/>
+          <p:cNvSpPr>
+            <a:spLocks noGrp="1"/>
+          </p:cNvSpPr>
+          <p:nvPr>
+            <p:ph type="title"/>
+          </p:nvPr>
+        </p:nvSpPr>
+        <p:spPr/>
+        <p:txBody>
+          <a:bodyPr/>
+          <a:lstStyle/>
+          <a:p>
+            <a:pPr/>
+            <a:r>
+              <a:rPr>
+                <a:solidFill>
+                  <a:schemeClr val="dk1"/>
+                </a:solidFill>
+              </a:rPr>
+              <a:t>Both models, 598 questions</a:t>
+            </a:r>
+          </a:p>
+        </p:txBody>
+      </p:sp>
+      <p:sp>
+        <p:nvSpPr>
+          <p:cNvPr id="3" name="Text Placeholder 2"/>
+          <p:cNvSpPr>
+            <a:spLocks noGrp="1"/>
+          </p:cNvSpPr>
+          <p:nvPr>
+            <p:ph type="body" idx="1"/>
+          </p:nvPr>
+        </p:nvSpPr>
+        <p:spPr>
+          <a:xfrm>
+            <a:off x="311700" y="1152475"/>
+            <a:ext cx="8520600" cy="450000"/>
+          </a:xfrm>
+        </p:spPr>
+        <p:txBody>
+          <a:bodyPr/>
+          <a:lstStyle/>
+          <a:p>
+            <a:pPr/>
+            <a:r>
+              <a:rPr>
+                <a:solidFill>
+                  <a:schemeClr val="dk1"/>
+                </a:solidFill>
+              </a:rPr>
+              <a:t>Q_noE (no "Cannot tell"): confidently wrong 16.6% Qwen, 15.2% InternVL.</a:t>
+            </a:r>
+          </a:p>
+        </p:txBody>
+      </p:sp>
+      <p:graphicFrame>
+        <p:nvGraphicFramePr>
+          <p:cNvPr id="4" name="Table 3"/>
+          <p:cNvGraphicFramePr>
+            <a:graphicFrameLocks noGrp="1"/>
+          </p:cNvGraphicFramePr>
+          <p:nvPr/>
+        </p:nvGraphicFramePr>
+        <p:xfrm>
+          <a:off x="311700" y="1682475"/>
+          <a:ext cx="8520600" cy="2240280"/>
+        </p:xfrm>
+        <a:graphic>
+          <a:graphicData uri="http://schemas.openxmlformats.org/drawingml/2006/table">
+            <a:tbl>
+              <a:tblPr firstRow="1" bandRow="1">
+                <a:tableStyleId>{5C22544A-7EE6-4342-B048-85BDC9FD1C3A}</a:tableStyleId>
+              </a:tblPr>
+              <a:tblGrid>
+                <a:gridCol w="1217228"/>
+                <a:gridCol w="1217228"/>
+                <a:gridCol w="1217228"/>
+                <a:gridCol w="1217228"/>
+                <a:gridCol w="1217228"/>
+                <a:gridCol w="1217228"/>
+                <a:gridCol w="1217232"/>
+              </a:tblGrid>
+              <a:tr h="320040">
+                <a:tc>
+                  <a:txBody>
+                    <a:bodyPr/>
+                    <a:lstStyle/>
+                    <a:p/>
+                  </a:txBody>
+                  <a:tcPr/>
+                </a:tc>
+                <a:tc>
+                  <a:txBody>
+                    <a:bodyPr/>
+                    <a:lstStyle/>
+                    <a:p>
+                      <a:r>
+                        <a:rPr sz="1200"/>
+                        <a:t>Model</a:t>
+                      </a:r>
+                    </a:p>
+                  </a:txBody>
+                  <a:tcPr/>
+                </a:tc>
+                <a:tc>
+                  <a:txBody>
+                    <a:bodyPr/>
+                    <a:lstStyle/>
+                    <a:p>
+                      <a:r>
+                        <a:rPr sz="1200"/>
+                        <a:t>Q</a:t>
+                      </a:r>
+                    </a:p>
+                  </a:txBody>
+                  <a:tcPr/>
+                </a:tc>
+                <a:tc>
+                  <a:txBody>
+                    <a:bodyPr/>
+                    <a:lstStyle/>
+                    <a:p>
+                      <a:r>
+                        <a:rPr sz="1200"/>
+                        <a:t>T</a:t>
+                      </a:r>
+                    </a:p>
+                  </a:txBody>
+                  <a:tcPr/>
+                </a:tc>
+                <a:tc>
+                  <a:txBody>
+                    <a:bodyPr/>
+                    <a:lstStyle/>
+                    <a:p>
+                      <a:r>
+                        <a:rPr sz="1200"/>
+                        <a:t>T_told</a:t>
+                      </a:r>
+                    </a:p>
+                  </a:txBody>
+                  <a:tcPr/>
+                </a:tc>
+                <a:tc>
+                  <a:txBody>
+                    <a:bodyPr/>
+                    <a:lstStyle/>
+                    <a:p>
+                      <a:r>
+                        <a:rPr sz="1200"/>
+                        <a:t>VT</a:t>
+                      </a:r>
+                    </a:p>
+                  </a:txBody>
+                  <a:tcPr/>
+                </a:tc>
+                <a:tc>
+                  <a:txBody>
+                    <a:bodyPr/>
+                    <a:lstStyle/>
+                    <a:p>
+                      <a:r>
+                        <a:rPr sz="1200"/>
+                        <a:t>VTmis</a:t>
+                      </a:r>
+                    </a:p>
+                  </a:txBody>
+                  <a:tcPr/>
+                </a:tc>
+              </a:tr>
+              <a:tr h="320040">
+                <a:tc>
+                  <a:txBody>
+                    <a:bodyPr/>
+                    <a:lstStyle/>
+                    <a:p>
+                      <a:r>
+                        <a:rPr sz="1200"/>
+                        <a:t>Abstained</a:t>
+                      </a:r>
+                    </a:p>
+                  </a:txBody>
+                  <a:tcPr/>
+                </a:tc>
+                <a:tc>
+                  <a:txBody>
+                    <a:bodyPr/>
+                    <a:lstStyle/>
+                    <a:p>
+                      <a:r>
+                        <a:rPr sz="1200"/>
+                        <a:t>Qwen</a:t>
+                      </a:r>
+                    </a:p>
+                  </a:txBody>
+                  <a:tcPr/>
+                </a:tc>
+                <a:tc>
+                  <a:txBody>
+                    <a:bodyPr/>
+                    <a:lstStyle/>
+                    <a:p>
+                      <a:r>
+                        <a:rPr sz="1200"/>
+                        <a:t>61.7%</a:t>
+                      </a:r>
+                    </a:p>
+                  </a:txBody>
+                  <a:tcPr/>
+                </a:tc>
+                <a:tc>
+                  <a:txBody>
+                    <a:bodyPr/>
+                    <a:lstStyle/>
+                    <a:p>
+                      <a:r>
+                        <a:rPr sz="1200"/>
+                        <a:t>47.5%</a:t>
+                      </a:r>
+                    </a:p>
+                  </a:txBody>
+                  <a:tcPr/>
+                </a:tc>
+                <a:tc>
+                  <a:txBody>
+                    <a:bodyPr/>
+                    <a:lstStyle/>
+                    <a:p>
+                      <a:r>
+                        <a:rPr sz="1200"/>
+                        <a:t>61.9%</a:t>
+                      </a:r>
+                    </a:p>
+                  </a:txBody>
+                  <a:tcPr/>
+                </a:tc>
+                <a:tc>
+                  <a:txBody>
+                    <a:bodyPr/>
+                    <a:lstStyle/>
+                    <a:p>
+                      <a:r>
+                        <a:rPr sz="1200"/>
+                        <a:t>29.4%</a:t>
+                      </a:r>
+                    </a:p>
+                  </a:txBody>
+                  <a:tcPr/>
+                </a:tc>
+                <a:tc>
+                  <a:txBody>
+                    <a:bodyPr/>
+                    <a:lstStyle/>
+                    <a:p>
+                      <a:r>
+                        <a:rPr sz="1200"/>
+                        <a:t>41.6%</a:t>
+                      </a:r>
+                    </a:p>
+                  </a:txBody>
+                  <a:tcPr/>
+                </a:tc>
+              </a:tr>
+              <a:tr h="320040">
+                <a:tc>
+                  <a:txBody>
+                    <a:bodyPr/>
+                    <a:lstStyle/>
+                    <a:p/>
+                  </a:txBody>
+                  <a:tcPr/>
+                </a:tc>
+                <a:tc>
+                  <a:txBody>
+                    <a:bodyPr/>
+                    <a:lstStyle/>
+                    <a:p>
+                      <a:r>
+                        <a:rPr sz="1200"/>
+                        <a:t>InternVL</a:t>
+                      </a:r>
+                    </a:p>
+                  </a:txBody>
+                  <a:tcPr/>
+                </a:tc>
+                <a:tc>
+                  <a:txBody>
+                    <a:bodyPr/>
+                    <a:lstStyle/>
+                    <a:p>
+                      <a:r>
+                        <a:rPr sz="1200"/>
+                        <a:t>58.7%</a:t>
+                      </a:r>
+                    </a:p>
+                  </a:txBody>
+                  <a:tcPr/>
+                </a:tc>
+                <a:tc>
+                  <a:txBody>
+                    <a:bodyPr/>
+                    <a:lstStyle/>
+                    <a:p>
+                      <a:r>
+                        <a:rPr sz="1200"/>
+                        <a:t>42.0%</a:t>
+                      </a:r>
+                    </a:p>
+                  </a:txBody>
+                  <a:tcPr/>
+                </a:tc>
+                <a:tc>
+                  <a:txBody>
+                    <a:bodyPr/>
+                    <a:lstStyle/>
+                    <a:p>
+                      <a:r>
+                        <a:rPr sz="1200"/>
+                        <a:t>53.8%</a:t>
+                      </a:r>
+                    </a:p>
+                  </a:txBody>
+                  <a:tcPr/>
+                </a:tc>
+                <a:tc>
+                  <a:txBody>
+                    <a:bodyPr/>
+                    <a:lstStyle/>
+                    <a:p>
+                      <a:r>
+                        <a:rPr sz="1200"/>
+                        <a:t>13.7%</a:t>
+                      </a:r>
+                    </a:p>
+                  </a:txBody>
+                  <a:tcPr/>
+                </a:tc>
+                <a:tc>
+                  <a:txBody>
+                    <a:bodyPr/>
+                    <a:lstStyle/>
+                    <a:p>
+                      <a:r>
+                        <a:rPr sz="1200"/>
+                        <a:t>15.7%</a:t>
+                      </a:r>
+                    </a:p>
+                  </a:txBody>
+                  <a:tcPr/>
+                </a:tc>
+              </a:tr>
+              <a:tr h="320040">
+                <a:tc>
+                  <a:txBody>
+                    <a:bodyPr/>
+                    <a:lstStyle/>
+                    <a:p>
+                      <a:r>
+                        <a:rPr sz="1200"/>
+                        <a:t>Best A-D answer right</a:t>
+                      </a:r>
+                    </a:p>
+                  </a:txBody>
+                  <a:tcPr/>
+                </a:tc>
+                <a:tc>
+                  <a:txBody>
+                    <a:bodyPr/>
+                    <a:lstStyle/>
+                    <a:p>
+                      <a:r>
+                        <a:rPr sz="1200"/>
+                        <a:t>Qwen</a:t>
+                      </a:r>
+                    </a:p>
+                  </a:txBody>
+                  <a:tcPr/>
+                </a:tc>
+                <a:tc>
+                  <a:txBody>
+                    <a:bodyPr/>
+                    <a:lstStyle/>
+                    <a:p>
+                      <a:r>
+                        <a:rPr sz="1200"/>
+                        <a:t>45.3%</a:t>
+                      </a:r>
+                    </a:p>
+                  </a:txBody>
+                  <a:tcPr/>
+                </a:tc>
+                <a:tc>
+                  <a:txBody>
+                    <a:bodyPr/>
+                    <a:lstStyle/>
+                    <a:p>
+                      <a:r>
+                        <a:rPr sz="1200"/>
+                        <a:t>54.7%</a:t>
+                      </a:r>
+                    </a:p>
+                  </a:txBody>
+                  <a:tcPr/>
+                </a:tc>
+                <a:tc>
+                  <a:txBody>
+                    <a:bodyPr/>
+                    <a:lstStyle/>
+                    <a:p>
+                      <a:r>
+                        <a:rPr sz="1200"/>
+                        <a:t>55.2%</a:t>
+                      </a:r>
+                    </a:p>
+                  </a:txBody>
+                  <a:tcPr/>
+                </a:tc>
+                <a:tc>
+                  <a:txBody>
+                    <a:bodyPr/>
+                    <a:lstStyle/>
+                    <a:p>
+                      <a:r>
+                        <a:rPr sz="1200"/>
+                        <a:t>56.2%</a:t>
+                      </a:r>
+                    </a:p>
+                  </a:txBody>
+                  <a:tcPr/>
+                </a:tc>
+                <a:tc>
+                  <a:txBody>
+                    <a:bodyPr/>
+                    <a:lstStyle/>
+                    <a:p>
+                      <a:r>
+                        <a:rPr sz="1200"/>
+                        <a:t>52.5%</a:t>
+                      </a:r>
+                    </a:p>
+                  </a:txBody>
+                  <a:tcPr/>
+                </a:tc>
+              </a:tr>
+              <a:tr h="320040">
+                <a:tc>
+                  <a:txBody>
+                    <a:bodyPr/>
+                    <a:lstStyle/>
+                    <a:p/>
+                  </a:txBody>
+                  <a:tcPr/>
+                </a:tc>
+                <a:tc>
+                  <a:txBody>
+                    <a:bodyPr/>
+                    <a:lstStyle/>
+                    <a:p>
+                      <a:r>
+                        <a:rPr sz="1200"/>
+                        <a:t>InternVL</a:t>
+                      </a:r>
+                    </a:p>
+                  </a:txBody>
+                  <a:tcPr/>
+                </a:tc>
+                <a:tc>
+                  <a:txBody>
+                    <a:bodyPr/>
+                    <a:lstStyle/>
+                    <a:p>
+                      <a:r>
+                        <a:rPr sz="1200"/>
+                        <a:t>43.0%</a:t>
+                      </a:r>
+                    </a:p>
+                  </a:txBody>
+                  <a:tcPr/>
+                </a:tc>
+                <a:tc>
+                  <a:txBody>
+                    <a:bodyPr/>
+                    <a:lstStyle/>
+                    <a:p>
+                      <a:r>
+                        <a:rPr sz="1200"/>
+                        <a:t>51.2%</a:t>
+                      </a:r>
+                    </a:p>
+                  </a:txBody>
+                  <a:tcPr/>
+                </a:tc>
+                <a:tc>
+                  <a:txBody>
+                    <a:bodyPr/>
+                    <a:lstStyle/>
+                    <a:p>
+                      <a:r>
+                        <a:rPr sz="1200"/>
+                        <a:t>52.7%</a:t>
+                      </a:r>
+                    </a:p>
+                  </a:txBody>
+                  <a:tcPr/>
+                </a:tc>
+                <a:tc>
+                  <a:txBody>
+                    <a:bodyPr/>
+                    <a:lstStyle/>
+                    <a:p>
+                      <a:r>
+                        <a:rPr sz="1200"/>
+                        <a:t>56.4%</a:t>
+                      </a:r>
+                    </a:p>
+                  </a:txBody>
+                  <a:tcPr/>
+                </a:tc>
+                <a:tc>
+                  <a:txBody>
+                    <a:bodyPr/>
+                    <a:lstStyle/>
+                    <a:p>
+                      <a:r>
+                        <a:rPr sz="1200"/>
+                        <a:t>49.0%</a:t>
+                      </a:r>
+                    </a:p>
+                  </a:txBody>
+                  <a:tcPr/>
+                </a:tc>
+              </a:tr>
+              <a:tr h="320040">
+                <a:tc>
+                  <a:txBody>
+                    <a:bodyPr/>
+                    <a:lstStyle/>
+                    <a:p>
+                      <a:r>
+                        <a:rPr sz="1200"/>
+                        <a:t>Confidently wrong (&gt;= 0.8)</a:t>
+                      </a:r>
+                    </a:p>
+                  </a:txBody>
+                  <a:tcPr/>
+                </a:tc>
+                <a:tc>
+                  <a:txBody>
+                    <a:bodyPr/>
+                    <a:lstStyle/>
+                    <a:p>
+                      <a:r>
+                        <a:rPr sz="1200"/>
+                        <a:t>Qwen</a:t>
+                      </a:r>
+                    </a:p>
+                  </a:txBody>
+                  <a:tcPr/>
+                </a:tc>
+                <a:tc>
+                  <a:txBody>
+                    <a:bodyPr/>
+                    <a:lstStyle/>
+                    <a:p>
+                      <a:r>
+                        <a:rPr sz="1200"/>
+                        <a:t>9.0%</a:t>
+                      </a:r>
+                    </a:p>
+                  </a:txBody>
+                  <a:tcPr/>
+                </a:tc>
+                <a:tc>
+                  <a:txBody>
+                    <a:bodyPr/>
+                    <a:lstStyle/>
+                    <a:p>
+                      <a:r>
+                        <a:rPr sz="1200"/>
+                        <a:t>12.0%</a:t>
+                      </a:r>
+                    </a:p>
+                  </a:txBody>
+                  <a:tcPr/>
+                </a:tc>
+                <a:tc>
+                  <a:txBody>
+                    <a:bodyPr/>
+                    <a:lstStyle/>
+                    <a:p>
+                      <a:r>
+                        <a:rPr sz="1200"/>
+                        <a:t>8.0%</a:t>
+                      </a:r>
+                    </a:p>
+                  </a:txBody>
+                  <a:tcPr/>
+                </a:tc>
+                <a:tc>
+                  <a:txBody>
+                    <a:bodyPr/>
+                    <a:lstStyle/>
+                    <a:p>
+                      <a:r>
+                        <a:rPr sz="1200"/>
+                        <a:t>13.9%</a:t>
+                      </a:r>
+                    </a:p>
+                  </a:txBody>
+                  <a:tcPr/>
+                </a:tc>
+                <a:tc>
+                  <a:txBody>
+                    <a:bodyPr/>
+                    <a:lstStyle/>
+                    <a:p>
+                      <a:r>
+                        <a:rPr sz="1200"/>
+                        <a:t>15.1%</a:t>
+                      </a:r>
+                    </a:p>
+                  </a:txBody>
+                  <a:tcPr/>
+                </a:tc>
+              </a:tr>
+              <a:tr h="320040">
+                <a:tc>
+                  <a:txBody>
+                    <a:bodyPr/>
+                    <a:lstStyle/>
+                    <a:p/>
+                  </a:txBody>
+                  <a:tcPr/>
+                </a:tc>
+                <a:tc>
+                  <a:txBody>
+                    <a:bodyPr/>
+                    <a:lstStyle/>
+                    <a:p>
+                      <a:r>
+                        <a:rPr sz="1200"/>
+                        <a:t>InternVL</a:t>
+                      </a:r>
+                    </a:p>
+                  </a:txBody>
+                  <a:tcPr/>
+                </a:tc>
+                <a:tc>
+                  <a:txBody>
+                    <a:bodyPr/>
+                    <a:lstStyle/>
+                    <a:p>
+                      <a:r>
+                        <a:rPr sz="1200"/>
+                        <a:t>9.2%</a:t>
+                      </a:r>
+                    </a:p>
+                  </a:txBody>
+                  <a:tcPr/>
+                </a:tc>
+                <a:tc>
+                  <a:txBody>
+                    <a:bodyPr/>
+                    <a:lstStyle/>
+                    <a:p>
+                      <a:r>
+                        <a:rPr sz="1200"/>
+                        <a:t>10.5%</a:t>
+                      </a:r>
+                    </a:p>
+                  </a:txBody>
+                  <a:tcPr/>
+                </a:tc>
+                <a:tc>
+                  <a:txBody>
+                    <a:bodyPr/>
+                    <a:lstStyle/>
+                    <a:p>
+                      <a:r>
+                        <a:rPr sz="1200"/>
+                        <a:t>7.7%</a:t>
+                      </a:r>
+                    </a:p>
+                  </a:txBody>
+                  <a:tcPr/>
+                </a:tc>
+                <a:tc>
+                  <a:txBody>
+                    <a:bodyPr/>
+                    <a:lstStyle/>
+                    <a:p>
+                      <a:r>
+                        <a:rPr sz="1200"/>
+                        <a:t>14.0%</a:t>
+                      </a:r>
+                    </a:p>
+                  </a:txBody>
+                  <a:tcPr/>
+                </a:tc>
+                <a:tc>
+                  <a:txBody>
+                    <a:bodyPr/>
+                    <a:lstStyle/>
+                    <a:p>
+                      <a:r>
+                        <a:rPr sz="1200"/>
+                        <a:t>13.9%</a:t>
+                      </a:r>
+                    </a:p>
+                  </a:txBody>
+                  <a:tcPr/>
+                </a:tc>
+              </a:tr>
+            </a:tbl>
+          </a:graphicData>
+        </a:graphic>
+      </p:graphicFrame>
+    </p:spTree>
+  </p:cSld>
+  <p:clrMapOvr>
+    <a:masterClrMapping/>
+  </p:clrMapOvr>
+</p:sld>
+</file>
+
+<file path=ppt/slides/slide89.xml><?xml version="1.0" encoding="utf-8"?>
+<p:sld xmlns:a="http://schemas.openxmlformats.org/drawingml/2006/main" xmlns:p="http://schemas.openxmlformats.org/presentationml/2006/main" xmlns:r="http://schemas.openxmlformats.org/officeDocument/2006/relationships">
+  <p:cSld>
+    <p:spTree>
+      <p:nvGrpSpPr>
+        <p:cNvPr id="1" name=""/>
+        <p:cNvGrpSpPr/>
+        <p:nvPr/>
+      </p:nvGrpSpPr>
+      <p:grpSpPr/>
+      <p:sp>
+        <p:nvSpPr>
+          <p:cNvPr id="2" name="Title 1"/>
+          <p:cNvSpPr>
+            <a:spLocks noGrp="1"/>
+          </p:cNvSpPr>
+          <p:nvPr>
+            <p:ph type="title"/>
+          </p:nvPr>
+        </p:nvSpPr>
+        <p:spPr/>
+        <p:txBody>
+          <a:bodyPr/>
+          <a:lstStyle/>
+          <a:p>
+            <a:pPr/>
+            <a:r>
+              <a:rPr>
+                <a:solidFill>
+                  <a:schemeClr val="dk1"/>
+                </a:solidFill>
+              </a:rPr>
+              <a:t>Abstention: same pattern, except for the wrong video</a:t>
+            </a:r>
+          </a:p>
+        </p:txBody>
+      </p:sp>
+      <p:sp>
+        <p:nvSpPr>
+          <p:cNvPr id="3" name="Text Placeholder 2"/>
+          <p:cNvSpPr>
+            <a:spLocks noGrp="1"/>
+          </p:cNvSpPr>
+          <p:nvPr>
+            <p:ph type="body" idx="1"/>
+          </p:nvPr>
+        </p:nvSpPr>
+        <p:spPr>
+          <a:xfrm>
+            <a:off x="311700" y="1152475"/>
+            <a:ext cx="8520600" cy="800000"/>
+          </a:xfrm>
+        </p:spPr>
+        <p:txBody>
+          <a:bodyPr/>
+          <a:lstStyle/>
+          <a:p>
+            <a:pPr/>
+            <a:r>
+              <a:rPr>
+                <a:solidFill>
+                  <a:schemeClr val="dk1"/>
+                </a:solidFill>
+              </a:rPr>
+              <a:t>Both abstain less with more evidence, more when told a video exists.</a:t>
+            </a:r>
+          </a:p>
+          <a:p>
+            <a:pPr/>
+            <a:r>
+              <a:rPr>
+                <a:solidFill>
+                  <a:schemeClr val="dk1"/>
+                </a:solidFill>
+              </a:rPr>
+              <a:t>Wrong video: Qwen 29% to 42% (p &lt; 0.001), InternVL 14% to 16% (p = 0.22).</a:t>
+            </a:r>
+          </a:p>
+        </p:txBody>
+      </p:sp>
+      <p:pic>
+        <p:nvPicPr>
+          <p:cNvPr id="4" name="Picture 3" descr="abstention_by_model.png"/>
+          <p:cNvPicPr>
+            <a:picLocks noChangeAspect="1"/>
+          </p:cNvPicPr>
+          <p:nvPr/>
+        </p:nvPicPr>
+        <p:blipFill>
+          <a:blip r:embed="rId2"/>
+          <a:stretch>
+            <a:fillRect/>
+          </a:stretch>
+        </p:blipFill>
+        <p:spPr>
+          <a:xfrm>
+            <a:off x="1335187" y="2002475"/>
+            <a:ext cx="6473625" cy="3021025"/>
+          </a:xfrm>
+          <a:prstGeom prst="rect">
+            <a:avLst/>
+          </a:prstGeom>
+        </p:spPr>
+      </p:pic>
+    </p:spTree>
+  </p:cSld>
+  <p:clrMapOvr>
+    <a:masterClrMapping/>
+  </p:clrMapOvr>
+</p:sld>
+</file>
+
 <file path=ppt/slides/slide9.xml><?xml version="1.0" encoding="utf-8"?>
 <p:sld xmlns:a="http://schemas.openxmlformats.org/drawingml/2006/main" xmlns:r="http://schemas.openxmlformats.org/officeDocument/2006/relationships" xmlns:mc="http://schemas.openxmlformats.org/markup-compatibility/2006" xmlns:mv="urn:schemas-microsoft-com:mac:vml" xmlns:p="http://schemas.openxmlformats.org/presentationml/2006/main" xmlns:c="http://schemas.openxmlformats.org/drawingml/2006/chart" xmlns:dgm="http://schemas.openxmlformats.org/drawingml/2006/diagram" xmlns:o="urn:schemas-microsoft-com:office:office" xmlns:v="urn:schemas-microsoft-com:vml" xmlns:pvml="urn:schemas-microsoft-com:office:powerpoint" xmlns:com="http://schemas.openxmlformats.org/drawingml/2006/compatibility" xmlns:p14="http://schemas.microsoft.com/office/powerpoint/2010/main" xmlns:p15="http://schemas.microsoft.com/office/powerpoint/2012/main" xmlns:ahyp="http://schemas.microsoft.com/office/drawing/2018/hyperlinkcolor">
   <p:cSld>
@@ -38646,6 +39715,510 @@
           </a:graphicData>
         </a:graphic>
       </p:graphicFrame>
+    </p:spTree>
+  </p:cSld>
+  <p:clrMapOvr>
+    <a:masterClrMapping/>
+  </p:clrMapOvr>
+</p:sld>
+</file>
+
+<file path=ppt/slides/slide90.xml><?xml version="1.0" encoding="utf-8"?>
+<p:sld xmlns:a="http://schemas.openxmlformats.org/drawingml/2006/main" xmlns:p="http://schemas.openxmlformats.org/presentationml/2006/main" xmlns:r="http://schemas.openxmlformats.org/officeDocument/2006/relationships">
+  <p:cSld>
+    <p:spTree>
+      <p:nvGrpSpPr>
+        <p:cNvPr id="1" name=""/>
+        <p:cNvGrpSpPr/>
+        <p:nvPr/>
+      </p:nvGrpSpPr>
+      <p:grpSpPr/>
+      <p:sp>
+        <p:nvSpPr>
+          <p:cNvPr id="2" name="Title 1"/>
+          <p:cNvSpPr>
+            <a:spLocks noGrp="1"/>
+          </p:cNvSpPr>
+          <p:nvPr>
+            <p:ph type="title"/>
+          </p:nvPr>
+        </p:nvSpPr>
+        <p:spPr/>
+        <p:txBody>
+          <a:bodyPr/>
+          <a:lstStyle/>
+          <a:p>
+            <a:pPr/>
+            <a:r>
+              <a:rPr>
+                <a:solidFill>
+                  <a:schemeClr val="dk1"/>
+                </a:solidFill>
+              </a:rPr>
+              <a:t>InternVL: the wrong video hurts, unnoticed</a:t>
+            </a:r>
+          </a:p>
+        </p:txBody>
+      </p:sp>
+      <p:sp>
+        <p:nvSpPr>
+          <p:cNvPr id="3" name="Text Placeholder 2"/>
+          <p:cNvSpPr>
+            <a:spLocks noGrp="1"/>
+          </p:cNvSpPr>
+          <p:nvPr>
+            <p:ph type="body" idx="1"/>
+          </p:nvPr>
+        </p:nvSpPr>
+        <p:spPr/>
+        <p:txBody>
+          <a:bodyPr/>
+          <a:lstStyle/>
+          <a:p>
+            <a:pPr/>
+            <a:r>
+              <a:rPr>
+                <a:solidFill>
+                  <a:schemeClr val="dk1"/>
+                </a:solidFill>
+              </a:rPr>
+              <a:t>Best A-D answer right: 56.4% with the right video, 49.0% with the wrong one (81 lost, 37 gained, p &lt; 0.001).</a:t>
+            </a:r>
+          </a:p>
+          <a:p>
+            <a:pPr lvl="1"/>
+            <a:r>
+              <a:rPr>
+                <a:solidFill>
+                  <a:schemeClr val="dk1"/>
+                </a:solidFill>
+              </a:rPr>
+              <a:t>Below the transcript alone (51.2%): the wrong video misleads it.</a:t>
+            </a:r>
+          </a:p>
+          <a:p>
+            <a:pPr/>
+            <a:r>
+              <a:rPr>
+                <a:solidFill>
+                  <a:schemeClr val="dk1"/>
+                </a:solidFill>
+              </a:rPr>
+              <a:t>Yet it abstains only 2 points more, and still says it used a video in 48%.</a:t>
+            </a:r>
+          </a:p>
+          <a:p>
+            <a:pPr/>
+            <a:r>
+              <a:rPr>
+                <a:solidFill>
+                  <a:schemeClr val="dk1"/>
+                </a:solidFill>
+              </a:rPr>
+              <a:t>Qwen: smaller loss (56.2% to 52.5%, p = 0.04), but abstains 12 points more.</a:t>
+            </a:r>
+          </a:p>
+          <a:p>
+            <a:pPr/>
+            <a:r>
+              <a:rPr>
+                <a:solidFill>
+                  <a:schemeClr val="dk1"/>
+                </a:solidFill>
+              </a:rPr>
+              <a:t>Neither model's explanations notice a wrong video (0 of 598 each, both judges).</a:t>
+            </a:r>
+          </a:p>
+          <a:p>
+            <a:pPr lvl="1"/>
+            <a:r>
+              <a:rPr>
+                <a:solidFill>
+                  <a:schemeClr val="dk1"/>
+                </a:solidFill>
+              </a:rPr>
+              <a:t>The one InternVL explanation flagged (right video) disputes the question's premise.</a:t>
+            </a:r>
+          </a:p>
+        </p:txBody>
+      </p:sp>
+    </p:spTree>
+  </p:cSld>
+  <p:clrMapOvr>
+    <a:masterClrMapping/>
+  </p:clrMapOvr>
+</p:sld>
+</file>
+
+<file path=ppt/slides/slide91.xml><?xml version="1.0" encoding="utf-8"?>
+<p:sld xmlns:a="http://schemas.openxmlformats.org/drawingml/2006/main" xmlns:p="http://schemas.openxmlformats.org/presentationml/2006/main" xmlns:r="http://schemas.openxmlformats.org/officeDocument/2006/relationships">
+  <p:cSld>
+    <p:spTree>
+      <p:nvGrpSpPr>
+        <p:cNvPr id="1" name=""/>
+        <p:cNvGrpSpPr/>
+        <p:nvPr/>
+      </p:nvGrpSpPr>
+      <p:grpSpPr/>
+      <p:sp>
+        <p:nvSpPr>
+          <p:cNvPr id="2" name="Title 1"/>
+          <p:cNvSpPr>
+            <a:spLocks noGrp="1"/>
+          </p:cNvSpPr>
+          <p:nvPr>
+            <p:ph type="title"/>
+          </p:nvPr>
+        </p:nvSpPr>
+        <p:spPr/>
+        <p:txBody>
+          <a:bodyPr/>
+          <a:lstStyle/>
+          <a:p>
+            <a:pPr/>
+            <a:r>
+              <a:rPr>
+                <a:solidFill>
+                  <a:schemeClr val="dk1"/>
+                </a:solidFill>
+              </a:rPr>
+              <a:t>Self-report: a video, not its relevance</a:t>
+            </a:r>
+          </a:p>
+        </p:txBody>
+      </p:sp>
+      <p:sp>
+        <p:nvSpPr>
+          <p:cNvPr id="3" name="Text Placeholder 2"/>
+          <p:cNvSpPr>
+            <a:spLocks noGrp="1"/>
+          </p:cNvSpPr>
+          <p:nvPr>
+            <p:ph type="body" idx="1"/>
+          </p:nvPr>
+        </p:nvSpPr>
+        <p:spPr>
+          <a:xfrm>
+            <a:off x="311700" y="1152475"/>
+            <a:ext cx="8520600" cy="800000"/>
+          </a:xfrm>
+        </p:spPr>
+        <p:txBody>
+          <a:bodyPr/>
+          <a:lstStyle/>
+          <a:p>
+            <a:pPr/>
+            <a:r>
+              <a:rPr>
+                <a:solidFill>
+                  <a:schemeClr val="dk1"/>
+                </a:solidFill>
+              </a:rPr>
+              <a:t>InternVL claims a video in 63% (right), 48% (wrong video), 14% (none).</a:t>
+            </a:r>
+          </a:p>
+          <a:p>
+            <a:pPr/>
+            <a:r>
+              <a:rPr>
+                <a:solidFill>
+                  <a:schemeClr val="dk1"/>
+                </a:solidFill>
+              </a:rPr>
+              <a:t>Qwen rarely claims one; both cite things seen with the wrong video.</a:t>
+            </a:r>
+          </a:p>
+        </p:txBody>
+      </p:sp>
+      <p:pic>
+        <p:nvPicPr>
+          <p:cNvPr id="4" name="Picture 3" descr="video_self_report_by_model.png"/>
+          <p:cNvPicPr>
+            <a:picLocks noChangeAspect="1"/>
+          </p:cNvPicPr>
+          <p:nvPr/>
+        </p:nvPicPr>
+        <p:blipFill>
+          <a:blip r:embed="rId2"/>
+          <a:stretch>
+            <a:fillRect/>
+          </a:stretch>
+        </p:blipFill>
+        <p:spPr>
+          <a:xfrm>
+            <a:off x="311700" y="2002475"/>
+            <a:ext cx="8520600" cy="2752809"/>
+          </a:xfrm>
+          <a:prstGeom prst="rect">
+            <a:avLst/>
+          </a:prstGeom>
+        </p:spPr>
+      </p:pic>
+    </p:spTree>
+  </p:cSld>
+  <p:clrMapOvr>
+    <a:masterClrMapping/>
+  </p:clrMapOvr>
+</p:sld>
+</file>
+
+<file path=ppt/slides/slide92.xml><?xml version="1.0" encoding="utf-8"?>
+<p:sld xmlns:a="http://schemas.openxmlformats.org/drawingml/2006/main" xmlns:p="http://schemas.openxmlformats.org/presentationml/2006/main" xmlns:r="http://schemas.openxmlformats.org/officeDocument/2006/relationships">
+  <p:cSld>
+    <p:spTree>
+      <p:nvGrpSpPr>
+        <p:cNvPr id="1" name=""/>
+        <p:cNvGrpSpPr/>
+        <p:nvPr/>
+      </p:nvGrpSpPr>
+      <p:grpSpPr/>
+      <p:sp>
+        <p:nvSpPr>
+          <p:cNvPr id="2" name="Title 1"/>
+          <p:cNvSpPr>
+            <a:spLocks noGrp="1"/>
+          </p:cNvSpPr>
+          <p:nvPr>
+            <p:ph type="title"/>
+          </p:nvPr>
+        </p:nvSpPr>
+        <p:spPr/>
+        <p:txBody>
+          <a:bodyPr/>
+          <a:lstStyle/>
+          <a:p>
+            <a:pPr/>
+            <a:r>
+              <a:rPr>
+                <a:solidFill>
+                  <a:schemeClr val="dk1"/>
+                </a:solidFill>
+              </a:rPr>
+              <a:t>Told a video exists (T_told): replicates</a:t>
+            </a:r>
+          </a:p>
+        </p:txBody>
+      </p:sp>
+      <p:sp>
+        <p:nvSpPr>
+          <p:cNvPr id="3" name="Text Placeholder 2"/>
+          <p:cNvSpPr>
+            <a:spLocks noGrp="1"/>
+          </p:cNvSpPr>
+          <p:nvPr>
+            <p:ph type="body" idx="1"/>
+          </p:nvPr>
+        </p:nvSpPr>
+        <p:spPr/>
+        <p:txBody>
+          <a:bodyPr/>
+          <a:lstStyle/>
+          <a:p>
+            <a:pPr/>
+            <a:r>
+              <a:rPr>
+                <a:solidFill>
+                  <a:schemeClr val="dk1"/>
+                </a:solidFill>
+              </a:rPr>
+              <a:t>Both abstain more: Qwen 47.5% to 61.9% (87 start, 1 stops), InternVL 42.0% to 53.8% (72 start, 1 stops).</a:t>
+            </a:r>
+          </a:p>
+          <a:p>
+            <a:pPr/>
+            <a:r>
+              <a:rPr>
+                <a:solidFill>
+                  <a:schemeClr val="dk1"/>
+                </a:solidFill>
+              </a:rPr>
+              <a:t>Mostly across the board: P("Cannot tell") rises only a little more where the video mattered.</a:t>
+            </a:r>
+          </a:p>
+          <a:p>
+            <a:pPr lvl="1"/>
+            <a:r>
+              <a:rPr>
+                <a:solidFill>
+                  <a:schemeClr val="dk1"/>
+                </a:solidFill>
+              </a:rPr>
+              <a:t>Qwen +0.14 vs +0.11; InternVL +0.10 vs +0.07 (both p &lt; 0.001).</a:t>
+            </a:r>
+          </a:p>
+          <a:p>
+            <a:pPr/>
+            <a:r>
+              <a:rPr>
+                <a:solidFill>
+                  <a:schemeClr val="dk1"/>
+                </a:solidFill>
+              </a:rPr>
+              <a:t>Explanations rarely name the missing video: Qwen 7.9%, InternVL 3.7%.</a:t>
+            </a:r>
+          </a:p>
+          <a:p>
+            <a:pPr/>
+            <a:r>
+              <a:rPr>
+                <a:solidFill>
+                  <a:schemeClr val="dk1"/>
+                </a:solidFill>
+              </a:rPr>
+              <a:t>InternVL: 5 T_told explanations refer to "the audio", though no audio is ever given.</a:t>
+            </a:r>
+          </a:p>
+        </p:txBody>
+      </p:sp>
+    </p:spTree>
+  </p:cSld>
+  <p:clrMapOvr>
+    <a:masterClrMapping/>
+  </p:clrMapOvr>
+</p:sld>
+</file>
+
+<file path=ppt/slides/slide93.xml><?xml version="1.0" encoding="utf-8"?>
+<p:sld xmlns:a="http://schemas.openxmlformats.org/drawingml/2006/main" xmlns:p="http://schemas.openxmlformats.org/presentationml/2006/main" xmlns:r="http://schemas.openxmlformats.org/officeDocument/2006/relationships">
+  <p:cSld>
+    <p:spTree>
+      <p:nvGrpSpPr>
+        <p:cNvPr id="1" name=""/>
+        <p:cNvGrpSpPr/>
+        <p:nvPr/>
+      </p:nvGrpSpPr>
+      <p:grpSpPr/>
+      <p:sp>
+        <p:nvSpPr>
+          <p:cNvPr id="2" name="Title 1"/>
+          <p:cNvSpPr>
+            <a:spLocks noGrp="1"/>
+          </p:cNvSpPr>
+          <p:nvPr>
+            <p:ph type="title"/>
+          </p:nvPr>
+        </p:nvSpPr>
+        <p:spPr/>
+        <p:txBody>
+          <a:bodyPr/>
+          <a:lstStyle/>
+          <a:p>
+            <a:pPr/>
+            <a:r>
+              <a:rPr>
+                <a:solidFill>
+                  <a:schemeClr val="dk1"/>
+                </a:solidFill>
+              </a:rPr>
+              <a:t>Takeaways</a:t>
+            </a:r>
+          </a:p>
+        </p:txBody>
+      </p:sp>
+      <p:sp>
+        <p:nvSpPr>
+          <p:cNvPr id="3" name="Text Placeholder 2"/>
+          <p:cNvSpPr>
+            <a:spLocks noGrp="1"/>
+          </p:cNvSpPr>
+          <p:nvPr>
+            <p:ph type="body" idx="1"/>
+          </p:nvPr>
+        </p:nvSpPr>
+        <p:spPr/>
+        <p:txBody>
+          <a:bodyPr/>
+          <a:lstStyle/>
+          <a:p>
+            <a:pPr/>
+            <a:r>
+              <a:rPr>
+                <a:solidFill>
+                  <a:schemeClr val="dk1"/>
+                </a:solidFill>
+              </a:rPr>
+              <a:t>Replicates across model families:</a:t>
+            </a:r>
+          </a:p>
+          <a:p>
+            <a:pPr lvl="1"/>
+            <a:r>
+              <a:rPr>
+                <a:solidFill>
+                  <a:schemeClr val="dk1"/>
+                </a:solidFill>
+              </a:rPr>
+              <a:t>abstention follows the evidence (C1); blanket caution when told evidence is missing;</a:t>
+            </a:r>
+          </a:p>
+          <a:p>
+            <a:pPr lvl="1"/>
+            <a:r>
+              <a:rPr>
+                <a:solidFill>
+                  <a:schemeClr val="dk1"/>
+                </a:solidFill>
+              </a:rPr>
+              <a:t>no explanation notices a video from the wrong film (C2).</a:t>
+            </a:r>
+          </a:p>
+          <a:p>
+            <a:pPr/>
+            <a:r>
+              <a:rPr>
+                <a:solidFill>
+                  <a:schemeClr val="dk1"/>
+                </a:solidFill>
+              </a:rPr>
+              <a:t>Differs: InternVL's abstention ignores the wrong video, though its accuracy drops.</a:t>
+            </a:r>
+          </a:p>
+          <a:p>
+            <a:pPr lvl="1"/>
+            <a:r>
+              <a:rPr>
+                <a:solidFill>
+                  <a:schemeClr val="dk1"/>
+                </a:solidFill>
+              </a:rPr>
+              <a:t>It reports using a video often, but about as often for the wrong one: self-report tracks</a:t>
+            </a:r>
+          </a:p>
+          <a:p>
+            <a:pPr lvl="1"/>
+            <a:r>
+              <a:rPr>
+                <a:solidFill>
+                  <a:schemeClr val="dk1"/>
+                </a:solidFill>
+              </a:rPr>
+              <a:t>whether a video is there, not whether it is relevant (C2).</a:t>
+            </a:r>
+          </a:p>
+          <a:p>
+            <a:pPr/>
+            <a:r>
+              <a:rPr>
+                <a:solidFill>
+                  <a:schemeClr val="dk1"/>
+                </a:solidFill>
+              </a:rPr>
+              <a:t>Caveats: two 7-8B open models; explanation codes are LLM-judge labels (not hand-checked).</a:t>
+            </a:r>
+          </a:p>
+          <a:p>
+            <a:pPr/>
+            <a:r>
+              <a:rPr>
+                <a:solidFill>
+                  <a:schemeClr val="dk1"/>
+                </a:solidFill>
+              </a:rPr>
+              <a:t>Next: write the study section of the paper.</a:t>
+            </a:r>
+          </a:p>
+        </p:txBody>
+      </p:sp>
     </p:spTree>
   </p:cSld>
   <p:clrMapOvr>

</xml_diff>